<commit_message>
Deck: load-test and test-footprint figures
</commit_message>
<xml_diff>
--- a/deck/Green-Corridor-Submission.pptx
+++ b/deck/Green-Corridor-Submission.pptx
@@ -9284,24 +9284,27 @@
         </p:nvSpPr>
         <p:spPr>
           <a:xfrm>
-            <a:off x="356616" y="3520440"/>
-            <a:ext cx="4023360" cy="868680"/>
+            <a:off x="356616" y="3383280"/>
+            <a:ext cx="4023360" cy="1371600"/>
           </a:xfrm>
           <a:prstGeom prst="roundRect">
             <a:avLst>
-              <a:gd name="adj" fmla="val 6315"/>
+              <a:gd name="adj" fmla="val 6666"/>
             </a:avLst>
           </a:prstGeom>
           <a:solidFill>
-            <a:srgbClr val="F3F4F6"/>
+            <a:srgbClr val="16171A"/>
           </a:solidFill>
-          <a:ln w="12700">
-            <a:solidFill>
-              <a:srgbClr val="9CA3AF"/>
-            </a:solidFill>
-            <a:prstDash val="dash"/>
+          <a:ln>
+            <a:noFill/>
           </a:ln>
-          <a:effectLst/>
+          <a:effectLst>
+            <a:outerShdw blurRad="101600" dist="25400" dir="5400000" algn="t" rotWithShape="0">
+              <a:srgbClr val="000000">
+                <a:alpha val="16000"/>
+              </a:srgbClr>
+            </a:outerShdw>
+          </a:effectLst>
         </p:spPr>
         <p:style>
           <a:lnRef idx="1">
@@ -9318,42 +9321,53 @@
           </a:fontRef>
         </p:style>
         <p:txBody>
-          <a:bodyPr rtlCol="0" anchor="ctr" wrap="square" lIns="182880" tIns="91440" rIns="182880" bIns="91440"/>
+          <a:bodyPr rtlCol="0" anchor="t" wrap="square" lIns="201168" tIns="182879" rIns="164592" bIns="91440"/>
           <a:lstStyle/>
           <a:p>
             <a:pPr algn="l">
               <a:spcAft>
-                <a:spcPts val="0"/>
+                <a:spcPts val="200"/>
               </a:spcAft>
             </a:pPr>
             <a:r>
-              <a:rPr sz="1400" b="1">
+              <a:rPr sz="3600" b="1">
                 <a:solidFill>
-                  <a:srgbClr val="6B7280"/>
+                  <a:srgbClr val="F59E0B"/>
                 </a:solidFill>
                 <a:latin typeface="Google Sans Flex"/>
                 <a:ea typeface="Google Sans Flex"/>
                 <a:cs typeface="Google Sans Flex"/>
               </a:rPr>
-              <a:t>[p50/p95 fill at freeze]</a:t>
+              <a:t>17 / 37</a:t>
             </a:r>
-          </a:p>
-          <a:p>
-            <a:pPr algn="l">
-              <a:spcAft>
-                <a:spcPts val="0"/>
-              </a:spcAft>
-            </a:pPr>
             <a:r>
-              <a:rPr sz="1100" b="0">
+              <a:rPr sz="1800" b="1">
                 <a:solidFill>
-                  <a:srgbClr val="6B7280"/>
+                  <a:srgbClr val="F59E0B"/>
                 </a:solidFill>
                 <a:latin typeface="Google Sans Flex"/>
                 <a:ea typeface="Google Sans Flex"/>
                 <a:cs typeface="Google Sans Flex"/>
               </a:rPr>
-              <a:t>Load test</a:t>
+              <a:t> ms</a:t>
+            </a:r>
+          </a:p>
+          <a:p>
+            <a:pPr algn="l">
+              <a:spcAft>
+                <a:spcPts val="200"/>
+              </a:spcAft>
+            </a:pPr>
+            <a:r>
+              <a:rPr sz="1400" b="0">
+                <a:solidFill>
+                  <a:srgbClr val="E5E7EB"/>
+                </a:solidFill>
+                <a:latin typeface="Google Sans Flex"/>
+                <a:ea typeface="Google Sans Flex"/>
+                <a:cs typeface="Google Sans Flex"/>
+              </a:rPr>
+              <a:t>/location p50 / p95, offline single instance</a:t>
             </a:r>
           </a:p>
         </p:txBody>
@@ -9366,8 +9380,8 @@
         </p:nvSpPr>
         <p:spPr>
           <a:xfrm>
-            <a:off x="4654296" y="3520440"/>
-            <a:ext cx="4133087" cy="868680"/>
+            <a:off x="4654296" y="3383280"/>
+            <a:ext cx="4133087" cy="1371600"/>
           </a:xfrm>
           <a:prstGeom prst="rect">
             <a:avLst/>
@@ -9394,7 +9408,7 @@
                 <a:ea typeface="Google Sans Flex"/>
                 <a:cs typeface="Google Sans Flex"/>
               </a:rPr>
-              <a:t>≈250 Python, 45 web tests; 98 % API coverage</a:t>
+              <a:t>344 Python, 138 web tests; 98 % API coverage</a:t>
             </a:r>
           </a:p>
         </p:txBody>

</xml_diff>